<commit_message>
Add PowerBI/PowerAutomate materials, Azure AI invoicing docs, and dbt resources
Co-Authored-By: Claude Sonnet 4.6 <noreply@anthropic.com>
</commit_message>
<xml_diff>
--- a/dbt/dbt.pptx
+++ b/dbt/dbt.pptx
@@ -6626,6 +6626,108 @@
           </a:prstGeom>
         </p:spPr>
       </p:pic>
+      <p:sp>
+        <p:nvSpPr>
+          <p:cNvPr id="13" name="TextBox 12">
+            <a:extLst>
+              <a:ext uri="{FF2B5EF4-FFF2-40B4-BE49-F238E27FC236}">
+                <a16:creationId xmlns:a16="http://schemas.microsoft.com/office/drawing/2014/main" id="{DE006ED9-2CE1-933A-8F33-2D52929572A0}"/>
+              </a:ext>
+            </a:extLst>
+          </p:cNvPr>
+          <p:cNvSpPr txBox="1"/>
+          <p:nvPr/>
+        </p:nvSpPr>
+        <p:spPr>
+          <a:xfrm>
+            <a:off x="228600" y="5190067"/>
+            <a:ext cx="6503113" cy="461665"/>
+          </a:xfrm>
+          <a:prstGeom prst="rect">
+            <a:avLst/>
+          </a:prstGeom>
+          <a:noFill/>
+        </p:spPr>
+        <p:txBody>
+          <a:bodyPr wrap="square" rtlCol="0">
+            <a:spAutoFit/>
+          </a:bodyPr>
+          <a:lstStyle/>
+          <a:p>
+            <a:r>
+              <a:rPr lang="fr-BE" sz="1200" dirty="0" err="1"/>
+              <a:t>Now</a:t>
+            </a:r>
+            <a:r>
+              <a:rPr lang="fr-BE" sz="1200" dirty="0"/>
+              <a:t> </a:t>
+            </a:r>
+          </a:p>
+          <a:p>
+            <a:r>
+              <a:rPr lang="fr-BE" sz="1200" dirty="0"/>
+              <a:t>1. </a:t>
+            </a:r>
+            <a:r>
+              <a:rPr lang="fr-BE" sz="1200" dirty="0" err="1"/>
+              <a:t>Create</a:t>
+            </a:r>
+            <a:r>
+              <a:rPr lang="fr-BE" sz="1200" dirty="0"/>
+              <a:t> 2 folders (</a:t>
+            </a:r>
+            <a:r>
+              <a:rPr lang="fr-BE" sz="1200" b="1" i="1" dirty="0" err="1"/>
+              <a:t>staging</a:t>
+            </a:r>
+            <a:r>
+              <a:rPr lang="fr-BE" sz="1200" dirty="0"/>
+              <a:t> , </a:t>
+            </a:r>
+            <a:r>
+              <a:rPr lang="fr-BE" sz="1200" b="1" i="1" dirty="0" err="1"/>
+              <a:t>mart</a:t>
+            </a:r>
+            <a:r>
+              <a:rPr lang="fr-BE" sz="1200" dirty="0"/>
+              <a:t> ) in the </a:t>
+            </a:r>
+            <a:r>
+              <a:rPr lang="fr-BE" sz="1200" dirty="0" err="1"/>
+              <a:t>models</a:t>
+            </a:r>
+            <a:r>
+              <a:rPr lang="fr-BE" sz="1200" dirty="0"/>
+              <a:t> folder  to </a:t>
+            </a:r>
+            <a:r>
+              <a:rPr lang="fr-BE" sz="1200" dirty="0" err="1"/>
+              <a:t>macth</a:t>
+            </a:r>
+            <a:r>
+              <a:rPr lang="fr-BE" sz="1200" dirty="0"/>
+              <a:t> </a:t>
+            </a:r>
+            <a:r>
+              <a:rPr lang="fr-BE" sz="1200" dirty="0" err="1"/>
+              <a:t>with</a:t>
+            </a:r>
+            <a:r>
+              <a:rPr lang="fr-BE" sz="1200" dirty="0"/>
+              <a:t> </a:t>
+            </a:r>
+            <a:r>
+              <a:rPr lang="fr-BE" sz="1200" dirty="0" err="1"/>
+              <a:t>project.yml</a:t>
+            </a:r>
+            <a:r>
+              <a:rPr lang="fr-BE" sz="1200" dirty="0"/>
+              <a:t> file </a:t>
+            </a:r>
+            <a:endParaRPr lang="en-BE" sz="1200" dirty="0"/>
+          </a:p>
+        </p:txBody>
+      </p:sp>
     </p:spTree>
     <p:extLst>
       <p:ext uri="{BB962C8B-B14F-4D97-AF65-F5344CB8AC3E}">
@@ -7002,7 +7104,7 @@
         </p:nvSpPr>
         <p:spPr>
           <a:xfrm>
-            <a:off x="5903408" y="4870287"/>
+            <a:off x="5903408" y="4878754"/>
             <a:ext cx="5645126" cy="1569660"/>
           </a:xfrm>
           <a:prstGeom prst="rect">
@@ -7136,6 +7238,66 @@
             <a:r>
               <a:rPr lang="fr-BE" sz="1200" dirty="0"/>
               <a:t>.</a:t>
+            </a:r>
+            <a:endParaRPr lang="en-BE" sz="1200" dirty="0"/>
+          </a:p>
+        </p:txBody>
+      </p:sp>
+      <p:sp>
+        <p:nvSpPr>
+          <p:cNvPr id="13" name="TextBox 12">
+            <a:extLst>
+              <a:ext uri="{FF2B5EF4-FFF2-40B4-BE49-F238E27FC236}">
+                <a16:creationId xmlns:a16="http://schemas.microsoft.com/office/drawing/2014/main" id="{F8289943-47CA-35DA-6DF4-1563BCAA67C0}"/>
+              </a:ext>
+            </a:extLst>
+          </p:cNvPr>
+          <p:cNvSpPr txBox="1"/>
+          <p:nvPr/>
+        </p:nvSpPr>
+        <p:spPr>
+          <a:xfrm>
+            <a:off x="7052733" y="745067"/>
+            <a:ext cx="3996267" cy="276999"/>
+          </a:xfrm>
+          <a:prstGeom prst="rect">
+            <a:avLst/>
+          </a:prstGeom>
+          <a:noFill/>
+        </p:spPr>
+        <p:txBody>
+          <a:bodyPr wrap="square" rtlCol="0">
+            <a:spAutoFit/>
+          </a:bodyPr>
+          <a:lstStyle/>
+          <a:p>
+            <a:r>
+              <a:rPr lang="fr-BE" sz="1200" dirty="0"/>
+              <a:t>0. </a:t>
+            </a:r>
+            <a:r>
+              <a:rPr lang="fr-BE" sz="1200" dirty="0" err="1"/>
+              <a:t>Create</a:t>
+            </a:r>
+            <a:r>
+              <a:rPr lang="fr-BE" sz="1200" dirty="0"/>
+              <a:t> a </a:t>
+            </a:r>
+            <a:r>
+              <a:rPr lang="fr-BE" sz="1200" b="1" i="1" dirty="0" err="1"/>
+              <a:t>source.yml</a:t>
+            </a:r>
+            <a:r>
+              <a:rPr lang="fr-BE" sz="1200" b="1" i="1" dirty="0"/>
+              <a:t> </a:t>
+            </a:r>
+            <a:r>
+              <a:rPr lang="fr-BE" sz="1200" dirty="0"/>
+              <a:t>file in the </a:t>
+            </a:r>
+            <a:r>
+              <a:rPr lang="fr-BE" sz="1200" dirty="0" err="1"/>
+              <a:t>staging</a:t>
             </a:r>
             <a:endParaRPr lang="en-BE" sz="1200" dirty="0"/>
           </a:p>

</xml_diff>